<commit_message>
feat(proposal): V8 - 費用感スライド追加 (PoC ¥200K + 月次 ¥90K = 初年度約 ¥1.28M)
</commit_message>
<xml_diff>
--- a/docs/proposals/Precision_PB_Blueprint_Aswan_editable_V7.pptx
+++ b/docs/proposals/Precision_PB_Blueprint_Aswan_editable_V7.pptx
@@ -4,6 +4,9 @@
   <p:sldMasterIdLst>
     <p:sldMasterId id="2147483648" r:id="rId1"/>
   </p:sldMasterIdLst>
+  <p:notesMasterIdLst>
+    <p:notesMasterId r:id="rId23"/>
+  </p:notesMasterIdLst>
   <p:sldIdLst>
     <p:sldId id="256" r:id="rId2"/>
     <p:sldId id="257" r:id="rId3"/>
@@ -25,7 +28,7 @@
     <p:sldId id="273" r:id="rId19"/>
     <p:sldId id="274" r:id="rId20"/>
     <p:sldId id="275" r:id="rId21"/>
-    <p:sldId id="276" r:id="rId27"/>
+    <p:sldId id="276" r:id="rId22"/>
   </p:sldIdLst>
   <p:sldSz cx="12192000" cy="6858000"/>
   <p:notesSz cx="6858000" cy="9144000"/>
@@ -144,7 +147,7 @@
 </file>
 
 <file path=ppt/notesMasters/notesMaster1.xml><?xml version="1.0" encoding="utf-8"?>
-<p:notesMaster xmlns:a="http://schemas.openxmlformats.org/drawingml/2006/main" xmlns:p="http://schemas.openxmlformats.org/presentationml/2006/main" xmlns:r="http://schemas.openxmlformats.org/officeDocument/2006/relationships">
+<p:notesMaster xmlns:a="http://schemas.openxmlformats.org/drawingml/2006/main" xmlns:r="http://schemas.openxmlformats.org/officeDocument/2006/relationships" xmlns:p="http://schemas.openxmlformats.org/presentationml/2006/main">
   <p:cSld>
     <p:bg>
       <p:bgRef idx="1001">
@@ -167,7 +170,7 @@
       </p:grpSpPr>
       <p:sp>
         <p:nvSpPr>
-          <p:cNvPr id="2" name="Header Placeholder 1"/>
+          <p:cNvPr id="2" name="ヘッダー プレースホルダー 1"/>
           <p:cNvSpPr>
             <a:spLocks noGrp="1"/>
           </p:cNvSpPr>
@@ -178,7 +181,7 @@
         <p:spPr>
           <a:xfrm>
             <a:off x="0" y="0"/>
-            <a:ext cx="2971800" cy="457200"/>
+            <a:ext cx="2971800" cy="458788"/>
           </a:xfrm>
           <a:prstGeom prst="rect">
             <a:avLst/>
@@ -192,13 +195,13 @@
             </a:lvl1pPr>
           </a:lstStyle>
           <a:p>
-            <a:endParaRPr lang="en-US"/>
-          </a:p>
-        </p:txBody>
-      </p:sp>
-      <p:sp>
-        <p:nvSpPr>
-          <p:cNvPr id="3" name="Date Placeholder 2"/>
+            <a:endParaRPr kumimoji="1" lang="ja-JP" altLang="en-US"/>
+          </a:p>
+        </p:txBody>
+      </p:sp>
+      <p:sp>
+        <p:nvSpPr>
+          <p:cNvPr id="3" name="日付プレースホルダー 2"/>
           <p:cNvSpPr>
             <a:spLocks noGrp="1"/>
           </p:cNvSpPr>
@@ -209,7 +212,7 @@
         <p:spPr>
           <a:xfrm>
             <a:off x="3884613" y="0"/>
-            <a:ext cx="2971800" cy="457200"/>
+            <a:ext cx="2971800" cy="458788"/>
           </a:xfrm>
           <a:prstGeom prst="rect">
             <a:avLst/>
@@ -223,17 +226,17 @@
             </a:lvl1pPr>
           </a:lstStyle>
           <a:p>
-            <a:fld id="{0F89C1C7-3DCD-1040-A9CF-14679D8B5DDD}" type="datetimeFigureOut">
-              <a:rPr lang="en-US" smtClean="0"/>
-              <a:t>10/17/16</a:t>
+            <a:fld id="{3C62E240-0D99-4251-9DB0-79EFD1B8E403}" type="datetimeFigureOut">
+              <a:rPr kumimoji="1" lang="ja-JP" altLang="en-US" smtClean="0"/>
+              <a:t>2026/5/19</a:t>
             </a:fld>
-            <a:endParaRPr lang="en-US"/>
-          </a:p>
-        </p:txBody>
-      </p:sp>
-      <p:sp>
-        <p:nvSpPr>
-          <p:cNvPr id="4" name="Slide Image Placeholder 3"/>
+            <a:endParaRPr kumimoji="1" lang="ja-JP" altLang="en-US"/>
+          </a:p>
+        </p:txBody>
+      </p:sp>
+      <p:sp>
+        <p:nvSpPr>
+          <p:cNvPr id="4" name="スライド イメージ プレースホルダー 3"/>
           <p:cNvSpPr>
             <a:spLocks noGrp="1" noRot="1" noChangeAspect="1"/>
           </p:cNvSpPr>
@@ -243,8 +246,8 @@
         </p:nvSpPr>
         <p:spPr>
           <a:xfrm>
-            <a:off x="1143000" y="685800"/>
-            <a:ext cx="4572000" cy="3429000"/>
+            <a:off x="685800" y="1143000"/>
+            <a:ext cx="5486400" cy="3086100"/>
           </a:xfrm>
           <a:prstGeom prst="rect">
             <a:avLst/>
@@ -260,13 +263,13 @@
           <a:bodyPr vert="horz" lIns="91440" tIns="45720" rIns="91440" bIns="45720" rtlCol="0" anchor="ctr"/>
           <a:lstStyle/>
           <a:p>
-            <a:endParaRPr lang="en-US"/>
-          </a:p>
-        </p:txBody>
-      </p:sp>
-      <p:sp>
-        <p:nvSpPr>
-          <p:cNvPr id="5" name="Notes Placeholder 4"/>
+            <a:endParaRPr lang="ja-JP" altLang="en-US"/>
+          </a:p>
+        </p:txBody>
+      </p:sp>
+      <p:sp>
+        <p:nvSpPr>
+          <p:cNvPr id="5" name="ノート プレースホルダー 4"/>
           <p:cNvSpPr>
             <a:spLocks noGrp="1"/>
           </p:cNvSpPr>
@@ -276,8 +279,8 @@
         </p:nvSpPr>
         <p:spPr>
           <a:xfrm>
-            <a:off x="685800" y="4343400"/>
-            <a:ext cx="5486400" cy="4114800"/>
+            <a:off x="685800" y="4400550"/>
+            <a:ext cx="5486400" cy="3600450"/>
           </a:xfrm>
           <a:prstGeom prst="rect">
             <a:avLst/>
@@ -289,44 +292,75 @@
           <a:p>
             <a:pPr lvl="0"/>
             <a:r>
-              <a:rPr lang="en-US" smtClean="0"/>
-              <a:t>Click to edit Master text styles</a:t>
+              <a:rPr kumimoji="1" lang="ja-JP" altLang="en-US"/>
+              <a:t>マスター テキストの書式設定</a:t>
             </a:r>
           </a:p>
           <a:p>
             <a:pPr lvl="1"/>
             <a:r>
-              <a:rPr lang="en-US" smtClean="0"/>
-              <a:t>Second level</a:t>
+              <a:rPr kumimoji="1" lang="ja-JP" altLang="en-US"/>
+              <a:t>第 </a:t>
+            </a:r>
+            <a:r>
+              <a:rPr kumimoji="1" lang="en-US" altLang="ja-JP"/>
+              <a:t>2 </a:t>
+            </a:r>
+            <a:r>
+              <a:rPr kumimoji="1" lang="ja-JP" altLang="en-US"/>
+              <a:t>レベル</a:t>
             </a:r>
           </a:p>
           <a:p>
             <a:pPr lvl="2"/>
             <a:r>
-              <a:rPr lang="en-US" smtClean="0"/>
-              <a:t>Third level</a:t>
+              <a:rPr kumimoji="1" lang="ja-JP" altLang="en-US"/>
+              <a:t>第 </a:t>
+            </a:r>
+            <a:r>
+              <a:rPr kumimoji="1" lang="en-US" altLang="ja-JP"/>
+              <a:t>3 </a:t>
+            </a:r>
+            <a:r>
+              <a:rPr kumimoji="1" lang="ja-JP" altLang="en-US"/>
+              <a:t>レベル</a:t>
             </a:r>
           </a:p>
           <a:p>
             <a:pPr lvl="3"/>
             <a:r>
-              <a:rPr lang="en-US" smtClean="0"/>
-              <a:t>Fourth level</a:t>
+              <a:rPr kumimoji="1" lang="ja-JP" altLang="en-US"/>
+              <a:t>第 </a:t>
+            </a:r>
+            <a:r>
+              <a:rPr kumimoji="1" lang="en-US" altLang="ja-JP"/>
+              <a:t>4 </a:t>
+            </a:r>
+            <a:r>
+              <a:rPr kumimoji="1" lang="ja-JP" altLang="en-US"/>
+              <a:t>レベル</a:t>
             </a:r>
           </a:p>
           <a:p>
             <a:pPr lvl="4"/>
             <a:r>
-              <a:rPr lang="en-US" smtClean="0"/>
-              <a:t>Fifth level</a:t>
-            </a:r>
-            <a:endParaRPr lang="en-US"/>
-          </a:p>
-        </p:txBody>
-      </p:sp>
-      <p:sp>
-        <p:nvSpPr>
-          <p:cNvPr id="6" name="Footer Placeholder 5"/>
+              <a:rPr kumimoji="1" lang="ja-JP" altLang="en-US"/>
+              <a:t>第 </a:t>
+            </a:r>
+            <a:r>
+              <a:rPr kumimoji="1" lang="en-US" altLang="ja-JP"/>
+              <a:t>5 </a:t>
+            </a:r>
+            <a:r>
+              <a:rPr kumimoji="1" lang="ja-JP" altLang="en-US"/>
+              <a:t>レベル</a:t>
+            </a:r>
+          </a:p>
+        </p:txBody>
+      </p:sp>
+      <p:sp>
+        <p:nvSpPr>
+          <p:cNvPr id="6" name="フッター プレースホルダー 5"/>
           <p:cNvSpPr>
             <a:spLocks noGrp="1"/>
           </p:cNvSpPr>
@@ -337,7 +371,7 @@
         <p:spPr>
           <a:xfrm>
             <a:off x="0" y="8685213"/>
-            <a:ext cx="2971800" cy="457200"/>
+            <a:ext cx="2971800" cy="458787"/>
           </a:xfrm>
           <a:prstGeom prst="rect">
             <a:avLst/>
@@ -351,13 +385,13 @@
             </a:lvl1pPr>
           </a:lstStyle>
           <a:p>
-            <a:endParaRPr lang="en-US"/>
-          </a:p>
-        </p:txBody>
-      </p:sp>
-      <p:sp>
-        <p:nvSpPr>
-          <p:cNvPr id="7" name="Slide Number Placeholder 6"/>
+            <a:endParaRPr kumimoji="1" lang="ja-JP" altLang="en-US"/>
+          </a:p>
+        </p:txBody>
+      </p:sp>
+      <p:sp>
+        <p:nvSpPr>
+          <p:cNvPr id="7" name="スライド番号プレースホルダー 6"/>
           <p:cNvSpPr>
             <a:spLocks noGrp="1"/>
           </p:cNvSpPr>
@@ -368,7 +402,7 @@
         <p:spPr>
           <a:xfrm>
             <a:off x="3884613" y="8685213"/>
-            <a:ext cx="2971800" cy="457200"/>
+            <a:ext cx="2971800" cy="458787"/>
           </a:xfrm>
           <a:prstGeom prst="rect">
             <a:avLst/>
@@ -382,25 +416,25 @@
             </a:lvl1pPr>
           </a:lstStyle>
           <a:p>
-            <a:fld id="{BB5E49A5-4136-284D-997B-48E1D791AD67}" type="slidenum">
-              <a:rPr lang="en-US" smtClean="0"/>
+            <a:fld id="{CEBDAC5E-E680-470D-A8EB-4FE189D8D5D1}" type="slidenum">
+              <a:rPr kumimoji="1" lang="ja-JP" altLang="en-US" smtClean="0"/>
               <a:t>‹#›</a:t>
             </a:fld>
-            <a:endParaRPr lang="en-US"/>
+            <a:endParaRPr kumimoji="1" lang="ja-JP" altLang="en-US"/>
           </a:p>
         </p:txBody>
       </p:sp>
     </p:spTree>
     <p:extLst>
       <p:ext uri="{BB962C8B-B14F-4D97-AF65-F5344CB8AC3E}">
-        <p14:creationId xmlns:p14="http://schemas.microsoft.com/office/powerpoint/2010/main" val="2623252185"/>
+        <p14:creationId xmlns:p14="http://schemas.microsoft.com/office/powerpoint/2010/main" val="1458098729"/>
       </p:ext>
     </p:extLst>
   </p:cSld>
   <p:clrMap bg1="lt1" tx1="dk1" bg2="lt2" tx2="dk2" accent1="accent1" accent2="accent2" accent3="accent3" accent4="accent4" accent5="accent5" accent6="accent6" hlink="hlink" folHlink="folHlink"/>
   <p:notesStyle>
-    <a:lvl1pPr marL="0" algn="l" defTabSz="457200" rtl="0" eaLnBrk="1" latinLnBrk="0" hangingPunct="1">
-      <a:defRPr sz="1200" kern="1200">
+    <a:lvl1pPr marL="0" algn="l" defTabSz="914400" rtl="0" eaLnBrk="1" latinLnBrk="0" hangingPunct="1">
+      <a:defRPr kumimoji="1" sz="1200" kern="1200">
         <a:solidFill>
           <a:schemeClr val="tx1"/>
         </a:solidFill>
@@ -409,8 +443,8 @@
         <a:cs typeface="+mn-cs"/>
       </a:defRPr>
     </a:lvl1pPr>
-    <a:lvl2pPr marL="457200" algn="l" defTabSz="457200" rtl="0" eaLnBrk="1" latinLnBrk="0" hangingPunct="1">
-      <a:defRPr sz="1200" kern="1200">
+    <a:lvl2pPr marL="457200" algn="l" defTabSz="914400" rtl="0" eaLnBrk="1" latinLnBrk="0" hangingPunct="1">
+      <a:defRPr kumimoji="1" sz="1200" kern="1200">
         <a:solidFill>
           <a:schemeClr val="tx1"/>
         </a:solidFill>
@@ -419,8 +453,8 @@
         <a:cs typeface="+mn-cs"/>
       </a:defRPr>
     </a:lvl2pPr>
-    <a:lvl3pPr marL="914400" algn="l" defTabSz="457200" rtl="0" eaLnBrk="1" latinLnBrk="0" hangingPunct="1">
-      <a:defRPr sz="1200" kern="1200">
+    <a:lvl3pPr marL="914400" algn="l" defTabSz="914400" rtl="0" eaLnBrk="1" latinLnBrk="0" hangingPunct="1">
+      <a:defRPr kumimoji="1" sz="1200" kern="1200">
         <a:solidFill>
           <a:schemeClr val="tx1"/>
         </a:solidFill>
@@ -429,8 +463,8 @@
         <a:cs typeface="+mn-cs"/>
       </a:defRPr>
     </a:lvl3pPr>
-    <a:lvl4pPr marL="1371600" algn="l" defTabSz="457200" rtl="0" eaLnBrk="1" latinLnBrk="0" hangingPunct="1">
-      <a:defRPr sz="1200" kern="1200">
+    <a:lvl4pPr marL="1371600" algn="l" defTabSz="914400" rtl="0" eaLnBrk="1" latinLnBrk="0" hangingPunct="1">
+      <a:defRPr kumimoji="1" sz="1200" kern="1200">
         <a:solidFill>
           <a:schemeClr val="tx1"/>
         </a:solidFill>
@@ -439,8 +473,8 @@
         <a:cs typeface="+mn-cs"/>
       </a:defRPr>
     </a:lvl4pPr>
-    <a:lvl5pPr marL="1828800" algn="l" defTabSz="457200" rtl="0" eaLnBrk="1" latinLnBrk="0" hangingPunct="1">
-      <a:defRPr sz="1200" kern="1200">
+    <a:lvl5pPr marL="1828800" algn="l" defTabSz="914400" rtl="0" eaLnBrk="1" latinLnBrk="0" hangingPunct="1">
+      <a:defRPr kumimoji="1" sz="1200" kern="1200">
         <a:solidFill>
           <a:schemeClr val="tx1"/>
         </a:solidFill>
@@ -449,8 +483,8 @@
         <a:cs typeface="+mn-cs"/>
       </a:defRPr>
     </a:lvl5pPr>
-    <a:lvl6pPr marL="2286000" algn="l" defTabSz="457200" rtl="0" eaLnBrk="1" latinLnBrk="0" hangingPunct="1">
-      <a:defRPr sz="1200" kern="1200">
+    <a:lvl6pPr marL="2286000" algn="l" defTabSz="914400" rtl="0" eaLnBrk="1" latinLnBrk="0" hangingPunct="1">
+      <a:defRPr kumimoji="1" sz="1200" kern="1200">
         <a:solidFill>
           <a:schemeClr val="tx1"/>
         </a:solidFill>
@@ -459,8 +493,8 @@
         <a:cs typeface="+mn-cs"/>
       </a:defRPr>
     </a:lvl6pPr>
-    <a:lvl7pPr marL="2743200" algn="l" defTabSz="457200" rtl="0" eaLnBrk="1" latinLnBrk="0" hangingPunct="1">
-      <a:defRPr sz="1200" kern="1200">
+    <a:lvl7pPr marL="2743200" algn="l" defTabSz="914400" rtl="0" eaLnBrk="1" latinLnBrk="0" hangingPunct="1">
+      <a:defRPr kumimoji="1" sz="1200" kern="1200">
         <a:solidFill>
           <a:schemeClr val="tx1"/>
         </a:solidFill>
@@ -469,8 +503,8 @@
         <a:cs typeface="+mn-cs"/>
       </a:defRPr>
     </a:lvl7pPr>
-    <a:lvl8pPr marL="3200400" algn="l" defTabSz="457200" rtl="0" eaLnBrk="1" latinLnBrk="0" hangingPunct="1">
-      <a:defRPr sz="1200" kern="1200">
+    <a:lvl8pPr marL="3200400" algn="l" defTabSz="914400" rtl="0" eaLnBrk="1" latinLnBrk="0" hangingPunct="1">
+      <a:defRPr kumimoji="1" sz="1200" kern="1200">
         <a:solidFill>
           <a:schemeClr val="tx1"/>
         </a:solidFill>
@@ -479,8 +513,8 @@
         <a:cs typeface="+mn-cs"/>
       </a:defRPr>
     </a:lvl8pPr>
-    <a:lvl9pPr marL="3657600" algn="l" defTabSz="457200" rtl="0" eaLnBrk="1" latinLnBrk="0" hangingPunct="1">
-      <a:defRPr sz="1200" kern="1200">
+    <a:lvl9pPr marL="3657600" algn="l" defTabSz="914400" rtl="0" eaLnBrk="1" latinLnBrk="0" hangingPunct="1">
+      <a:defRPr kumimoji="1" sz="1200" kern="1200">
         <a:solidFill>
           <a:schemeClr val="tx1"/>
         </a:solidFill>
@@ -494,7 +528,7 @@
 </file>
 
 <file path=ppt/notesSlides/notesSlide1.xml><?xml version="1.0" encoding="utf-8"?>
-<p:notes xmlns:a="http://schemas.openxmlformats.org/drawingml/2006/main" xmlns:p="http://schemas.openxmlformats.org/presentationml/2006/main" xmlns:r="http://schemas.openxmlformats.org/officeDocument/2006/relationships">
+<p:notes xmlns:a="http://schemas.openxmlformats.org/drawingml/2006/main" xmlns:r="http://schemas.openxmlformats.org/officeDocument/2006/relationships" xmlns:p="http://schemas.openxmlformats.org/presentationml/2006/main">
   <p:cSld>
     <p:spTree>
       <p:nvGrpSpPr>
@@ -514,7 +548,7 @@
         <p:nvSpPr>
           <p:cNvPr id="2" name="Slide Image Placeholder 1"/>
           <p:cNvSpPr>
-            <a:spLocks noGrp="1"/>
+            <a:spLocks noGrp="1" noRot="1" noChangeAspect="1"/>
           </p:cNvSpPr>
           <p:nvPr>
             <p:ph type="sldImg" idx="2"/>
@@ -529,7 +563,7 @@
             <a:spLocks noGrp="1"/>
           </p:cNvSpPr>
           <p:nvPr>
-            <p:ph type="body" idx="3" sz="quarter"/>
+            <p:ph type="body" sz="quarter" idx="3"/>
           </p:nvPr>
         </p:nvSpPr>
         <p:spPr/>
@@ -580,7 +614,7 @@
             <a:spLocks noGrp="1"/>
           </p:cNvSpPr>
           <p:nvPr>
-            <p:ph type="sldNum" idx="5" sz="quarter"/>
+            <p:ph type="sldNum" sz="quarter" idx="5"/>
           </p:nvPr>
         </p:nvSpPr>
         <p:spPr/>
@@ -594,7 +628,7 @@
 </file>
 
 <file path=ppt/notesSlides/notesSlide2.xml><?xml version="1.0" encoding="utf-8"?>
-<p:notes xmlns:a="http://schemas.openxmlformats.org/drawingml/2006/main" xmlns:p="http://schemas.openxmlformats.org/presentationml/2006/main" xmlns:r="http://schemas.openxmlformats.org/officeDocument/2006/relationships">
+<p:notes xmlns:a="http://schemas.openxmlformats.org/drawingml/2006/main" xmlns:r="http://schemas.openxmlformats.org/officeDocument/2006/relationships" xmlns:p="http://schemas.openxmlformats.org/presentationml/2006/main">
   <p:cSld>
     <p:spTree>
       <p:nvGrpSpPr>
@@ -614,7 +648,7 @@
         <p:nvSpPr>
           <p:cNvPr id="2" name="Slide Image Placeholder 1"/>
           <p:cNvSpPr>
-            <a:spLocks noGrp="1"/>
+            <a:spLocks noGrp="1" noRot="1" noChangeAspect="1"/>
           </p:cNvSpPr>
           <p:nvPr>
             <p:ph type="sldImg" idx="2"/>
@@ -629,7 +663,7 @@
             <a:spLocks noGrp="1"/>
           </p:cNvSpPr>
           <p:nvPr>
-            <p:ph type="body" idx="3" sz="quarter"/>
+            <p:ph type="body" sz="quarter" idx="3"/>
           </p:nvPr>
         </p:nvSpPr>
         <p:spPr/>
@@ -670,7 +704,7 @@
             <a:spLocks noGrp="1"/>
           </p:cNvSpPr>
           <p:nvPr>
-            <p:ph type="sldNum" idx="5" sz="quarter"/>
+            <p:ph type="sldNum" sz="quarter" idx="5"/>
           </p:nvPr>
         </p:nvSpPr>
         <p:spPr/>
@@ -684,7 +718,7 @@
 </file>
 
 <file path=ppt/notesSlides/notesSlide3.xml><?xml version="1.0" encoding="utf-8"?>
-<p:notes xmlns:a="http://schemas.openxmlformats.org/drawingml/2006/main" xmlns:p="http://schemas.openxmlformats.org/presentationml/2006/main" xmlns:r="http://schemas.openxmlformats.org/officeDocument/2006/relationships">
+<p:notes xmlns:a="http://schemas.openxmlformats.org/drawingml/2006/main" xmlns:r="http://schemas.openxmlformats.org/officeDocument/2006/relationships" xmlns:p="http://schemas.openxmlformats.org/presentationml/2006/main">
   <p:cSld>
     <p:spTree>
       <p:nvGrpSpPr>
@@ -704,7 +738,7 @@
         <p:nvSpPr>
           <p:cNvPr id="2" name="Slide Image Placeholder 1"/>
           <p:cNvSpPr>
-            <a:spLocks noGrp="1"/>
+            <a:spLocks noGrp="1" noRot="1" noChangeAspect="1"/>
           </p:cNvSpPr>
           <p:nvPr>
             <p:ph type="sldImg" idx="2"/>
@@ -719,7 +753,7 @@
             <a:spLocks noGrp="1"/>
           </p:cNvSpPr>
           <p:nvPr>
-            <p:ph type="body" idx="3" sz="quarter"/>
+            <p:ph type="body" sz="quarter" idx="3"/>
           </p:nvPr>
         </p:nvSpPr>
         <p:spPr/>
@@ -770,7 +804,7 @@
             <a:spLocks noGrp="1"/>
           </p:cNvSpPr>
           <p:nvPr>
-            <p:ph type="sldNum" idx="5" sz="quarter"/>
+            <p:ph type="sldNum" sz="quarter" idx="5"/>
           </p:nvPr>
         </p:nvSpPr>
         <p:spPr/>
@@ -784,7 +818,7 @@
 </file>
 
 <file path=ppt/notesSlides/notesSlide4.xml><?xml version="1.0" encoding="utf-8"?>
-<p:notes xmlns:a="http://schemas.openxmlformats.org/drawingml/2006/main" xmlns:p="http://schemas.openxmlformats.org/presentationml/2006/main" xmlns:r="http://schemas.openxmlformats.org/officeDocument/2006/relationships">
+<p:notes xmlns:a="http://schemas.openxmlformats.org/drawingml/2006/main" xmlns:r="http://schemas.openxmlformats.org/officeDocument/2006/relationships" xmlns:p="http://schemas.openxmlformats.org/presentationml/2006/main">
   <p:cSld>
     <p:spTree>
       <p:nvGrpSpPr>
@@ -804,7 +838,7 @@
         <p:nvSpPr>
           <p:cNvPr id="2" name="Slide Image Placeholder 1"/>
           <p:cNvSpPr>
-            <a:spLocks noGrp="1"/>
+            <a:spLocks noGrp="1" noRot="1" noChangeAspect="1"/>
           </p:cNvSpPr>
           <p:nvPr>
             <p:ph type="sldImg" idx="2"/>
@@ -819,7 +853,7 @@
             <a:spLocks noGrp="1"/>
           </p:cNvSpPr>
           <p:nvPr>
-            <p:ph type="body" idx="3" sz="quarter"/>
+            <p:ph type="body" sz="quarter" idx="3"/>
           </p:nvPr>
         </p:nvSpPr>
         <p:spPr/>
@@ -860,7 +894,7 @@
             <a:spLocks noGrp="1"/>
           </p:cNvSpPr>
           <p:nvPr>
-            <p:ph type="sldNum" idx="5" sz="quarter"/>
+            <p:ph type="sldNum" sz="quarter" idx="5"/>
           </p:nvPr>
         </p:nvSpPr>
         <p:spPr/>
@@ -1052,7 +1086,7 @@
           <a:p>
             <a:fld id="{5BCAD085-E8A6-8845-BD4E-CB4CCA059FC4}" type="datetimeFigureOut">
               <a:rPr lang="en-US" smtClean="0"/>
-              <a:t>5/14/2026</a:t>
+              <a:t>5/19/2026</a:t>
             </a:fld>
             <a:endParaRPr lang="en-US"/>
           </a:p>
@@ -1220,7 +1254,7 @@
           <a:p>
             <a:fld id="{5BCAD085-E8A6-8845-BD4E-CB4CCA059FC4}" type="datetimeFigureOut">
               <a:rPr lang="en-US" smtClean="0"/>
-              <a:t>5/14/2026</a:t>
+              <a:t>5/19/2026</a:t>
             </a:fld>
             <a:endParaRPr lang="en-US"/>
           </a:p>
@@ -1398,7 +1432,7 @@
           <a:p>
             <a:fld id="{5BCAD085-E8A6-8845-BD4E-CB4CCA059FC4}" type="datetimeFigureOut">
               <a:rPr lang="en-US" smtClean="0"/>
-              <a:t>5/14/2026</a:t>
+              <a:t>5/19/2026</a:t>
             </a:fld>
             <a:endParaRPr lang="en-US"/>
           </a:p>
@@ -1566,7 +1600,7 @@
           <a:p>
             <a:fld id="{5BCAD085-E8A6-8845-BD4E-CB4CCA059FC4}" type="datetimeFigureOut">
               <a:rPr lang="en-US" smtClean="0"/>
-              <a:t>5/14/2026</a:t>
+              <a:t>5/19/2026</a:t>
             </a:fld>
             <a:endParaRPr lang="en-US"/>
           </a:p>
@@ -1811,7 +1845,7 @@
           <a:p>
             <a:fld id="{5BCAD085-E8A6-8845-BD4E-CB4CCA059FC4}" type="datetimeFigureOut">
               <a:rPr lang="en-US" smtClean="0"/>
-              <a:t>5/14/2026</a:t>
+              <a:t>5/19/2026</a:t>
             </a:fld>
             <a:endParaRPr lang="en-US"/>
           </a:p>
@@ -2096,7 +2130,7 @@
           <a:p>
             <a:fld id="{5BCAD085-E8A6-8845-BD4E-CB4CCA059FC4}" type="datetimeFigureOut">
               <a:rPr lang="en-US" smtClean="0"/>
-              <a:t>5/14/2026</a:t>
+              <a:t>5/19/2026</a:t>
             </a:fld>
             <a:endParaRPr lang="en-US"/>
           </a:p>
@@ -2515,7 +2549,7 @@
           <a:p>
             <a:fld id="{5BCAD085-E8A6-8845-BD4E-CB4CCA059FC4}" type="datetimeFigureOut">
               <a:rPr lang="en-US" smtClean="0"/>
-              <a:t>5/14/2026</a:t>
+              <a:t>5/19/2026</a:t>
             </a:fld>
             <a:endParaRPr lang="en-US"/>
           </a:p>
@@ -2632,7 +2666,7 @@
           <a:p>
             <a:fld id="{5BCAD085-E8A6-8845-BD4E-CB4CCA059FC4}" type="datetimeFigureOut">
               <a:rPr lang="en-US" smtClean="0"/>
-              <a:t>5/14/2026</a:t>
+              <a:t>5/19/2026</a:t>
             </a:fld>
             <a:endParaRPr lang="en-US"/>
           </a:p>
@@ -2727,7 +2761,7 @@
           <a:p>
             <a:fld id="{5BCAD085-E8A6-8845-BD4E-CB4CCA059FC4}" type="datetimeFigureOut">
               <a:rPr lang="en-US" smtClean="0"/>
-              <a:t>5/14/2026</a:t>
+              <a:t>5/19/2026</a:t>
             </a:fld>
             <a:endParaRPr lang="en-US"/>
           </a:p>
@@ -3002,7 +3036,7 @@
           <a:p>
             <a:fld id="{5BCAD085-E8A6-8845-BD4E-CB4CCA059FC4}" type="datetimeFigureOut">
               <a:rPr lang="en-US" smtClean="0"/>
-              <a:t>5/14/2026</a:t>
+              <a:t>5/19/2026</a:t>
             </a:fld>
             <a:endParaRPr lang="en-US"/>
           </a:p>
@@ -3254,7 +3288,7 @@
           <a:p>
             <a:fld id="{5BCAD085-E8A6-8845-BD4E-CB4CCA059FC4}" type="datetimeFigureOut">
               <a:rPr lang="en-US" smtClean="0"/>
-              <a:t>5/14/2026</a:t>
+              <a:t>5/19/2026</a:t>
             </a:fld>
             <a:endParaRPr lang="en-US"/>
           </a:p>
@@ -3465,7 +3499,7 @@
           <a:p>
             <a:fld id="{5BCAD085-E8A6-8845-BD4E-CB4CCA059FC4}" type="datetimeFigureOut">
               <a:rPr lang="en-US" smtClean="0"/>
-              <a:t>5/14/2026</a:t>
+              <a:t>5/19/2026</a:t>
             </a:fld>
             <a:endParaRPr lang="en-US"/>
           </a:p>
@@ -13029,7 +13063,7 @@
           <p:nvPr>
             <p:extLst>
               <p:ext uri="{D42A27DB-BD31-4B8C-83A1-F6EECF244321}">
-                <p14:modId xmlns:p14="http://schemas.microsoft.com/office/powerpoint/2010/main" val="215217922"/>
+                <p14:modId xmlns:p14="http://schemas.microsoft.com/office/powerpoint/2010/main" val="2779414933"/>
               </p:ext>
             </p:extLst>
           </p:nvPr>
@@ -13155,7 +13189,8 @@
                           <a:solidFill>
                             <a:srgbClr val="111827"/>
                           </a:solidFill>
-                          <a:latin typeface="Noto Sans JP"/>
+                          <a:latin typeface="BIZ UDPゴシック" panose="020B0400000000000000" pitchFamily="50" charset="-128"/>
+                          <a:ea typeface="BIZ UDPゴシック" panose="020B0400000000000000" pitchFamily="50" charset="-128"/>
                         </a:rPr>
                         <a:t>①</a:t>
                       </a:r>
@@ -13178,7 +13213,8 @@
                           <a:solidFill>
                             <a:srgbClr val="111827"/>
                           </a:solidFill>
-                          <a:latin typeface="Noto Sans JP"/>
+                          <a:latin typeface="BIZ UDPゴシック" panose="020B0400000000000000" pitchFamily="50" charset="-128"/>
+                          <a:ea typeface="BIZ UDPゴシック" panose="020B0400000000000000" pitchFamily="50" charset="-128"/>
                         </a:rPr>
                         <a:t>PoC 範囲合意（対象カテゴリ・成功定義）</a:t>
                       </a:r>
@@ -13201,7 +13237,8 @@
                           <a:solidFill>
                             <a:srgbClr val="111827"/>
                           </a:solidFill>
-                          <a:latin typeface="Noto Sans JP"/>
+                          <a:latin typeface="BIZ UDPゴシック" panose="020B0400000000000000" pitchFamily="50" charset="-128"/>
+                          <a:ea typeface="BIZ UDPゴシック" panose="020B0400000000000000" pitchFamily="50" charset="-128"/>
                         </a:rPr>
                         <a:t>〜2週間</a:t>
                       </a:r>
@@ -13231,7 +13268,8 @@
                           <a:solidFill>
                             <a:srgbClr val="111827"/>
                           </a:solidFill>
-                          <a:latin typeface="Noto Sans JP"/>
+                          <a:latin typeface="BIZ UDPゴシック" panose="020B0400000000000000" pitchFamily="50" charset="-128"/>
+                          <a:ea typeface="BIZ UDPゴシック" panose="020B0400000000000000" pitchFamily="50" charset="-128"/>
                         </a:rPr>
                         <a:t>②</a:t>
                       </a:r>
@@ -13254,7 +13292,8 @@
                           <a:solidFill>
                             <a:srgbClr val="111827"/>
                           </a:solidFill>
-                          <a:latin typeface="Noto Sans JP"/>
+                          <a:latin typeface="BIZ UDPゴシック" panose="020B0400000000000000" pitchFamily="50" charset="-128"/>
+                          <a:ea typeface="BIZ UDPゴシック" panose="020B0400000000000000" pitchFamily="50" charset="-128"/>
                         </a:rPr>
                         <a:t>データ提供（POS・既存マスタ・監視対象）</a:t>
                       </a:r>
@@ -13273,14 +13312,32 @@
                     <a:p>
                       <a:pPr algn="l"/>
                       <a:r>
-                        <a:rPr sz="1400" b="0">
+                        <a:rPr lang="en-US" altLang="ja-JP" sz="1400" b="0">
                           <a:solidFill>
                             <a:srgbClr val="111827"/>
                           </a:solidFill>
-                          <a:latin typeface="Noto Sans JP"/>
+                          <a:latin typeface="BIZ UDPゴシック" panose="020B0400000000000000" pitchFamily="50" charset="-128"/>
+                          <a:ea typeface="BIZ UDPゴシック" panose="020B0400000000000000" pitchFamily="50" charset="-128"/>
                         </a:rPr>
-                        <a:t>〜4週間</a:t>
+                        <a:t>〜1</a:t>
                       </a:r>
+                      <a:r>
+                        <a:rPr lang="ja-JP" altLang="en-US" sz="1400" b="0">
+                          <a:solidFill>
+                            <a:srgbClr val="111827"/>
+                          </a:solidFill>
+                          <a:latin typeface="BIZ UDPゴシック" panose="020B0400000000000000" pitchFamily="50" charset="-128"/>
+                          <a:ea typeface="BIZ UDPゴシック" panose="020B0400000000000000" pitchFamily="50" charset="-128"/>
+                        </a:rPr>
+                        <a:t>週間</a:t>
+                      </a:r>
+                      <a:endParaRPr sz="1400" b="0">
+                        <a:solidFill>
+                          <a:srgbClr val="111827"/>
+                        </a:solidFill>
+                        <a:latin typeface="BIZ UDPゴシック" panose="020B0400000000000000" pitchFamily="50" charset="-128"/>
+                        <a:ea typeface="BIZ UDPゴシック" panose="020B0400000000000000" pitchFamily="50" charset="-128"/>
+                      </a:endParaRPr>
                     </a:p>
                   </a:txBody>
                   <a:tcPr marL="80000" marR="80000" marT="40000" marB="40000">
@@ -13307,7 +13364,8 @@
                           <a:solidFill>
                             <a:srgbClr val="111827"/>
                           </a:solidFill>
-                          <a:latin typeface="Noto Sans JP"/>
+                          <a:latin typeface="BIZ UDPゴシック" panose="020B0400000000000000" pitchFamily="50" charset="-128"/>
+                          <a:ea typeface="BIZ UDPゴシック" panose="020B0400000000000000" pitchFamily="50" charset="-128"/>
                         </a:rPr>
                         <a:t>③</a:t>
                       </a:r>
@@ -13330,10 +13388,28 @@
                           <a:solidFill>
                             <a:srgbClr val="111827"/>
                           </a:solidFill>
-                          <a:latin typeface="Noto Sans JP"/>
+                          <a:latin typeface="BIZ UDPゴシック" panose="020B0400000000000000" pitchFamily="50" charset="-128"/>
+                          <a:ea typeface="BIZ UDPゴシック" panose="020B0400000000000000" pitchFamily="50" charset="-128"/>
                         </a:rPr>
-                        <a:t>キックオフ／3Cレポート初回出力</a:t>
+                        <a:t>3Cレポート初回出力</a:t>
                       </a:r>
+                      <a:r>
+                        <a:rPr lang="ja-JP" altLang="en-US" sz="1400" b="0">
+                          <a:solidFill>
+                            <a:srgbClr val="111827"/>
+                          </a:solidFill>
+                          <a:latin typeface="BIZ UDPゴシック" panose="020B0400000000000000" pitchFamily="50" charset="-128"/>
+                          <a:ea typeface="BIZ UDPゴシック" panose="020B0400000000000000" pitchFamily="50" charset="-128"/>
+                        </a:rPr>
+                        <a:t>～仕様変更</a:t>
+                      </a:r>
+                      <a:endParaRPr sz="1400" b="0">
+                        <a:solidFill>
+                          <a:srgbClr val="111827"/>
+                        </a:solidFill>
+                        <a:latin typeface="BIZ UDPゴシック" panose="020B0400000000000000" pitchFamily="50" charset="-128"/>
+                        <a:ea typeface="BIZ UDPゴシック" panose="020B0400000000000000" pitchFamily="50" charset="-128"/>
+                      </a:endParaRPr>
                     </a:p>
                   </a:txBody>
                   <a:tcPr marL="80000" marR="80000" marT="40000" marB="40000">
@@ -13353,9 +13429,30 @@
                           <a:solidFill>
                             <a:srgbClr val="111827"/>
                           </a:solidFill>
-                          <a:latin typeface="Noto Sans JP"/>
+                          <a:latin typeface="BIZ UDPゴシック" panose="020B0400000000000000" pitchFamily="50" charset="-128"/>
+                          <a:ea typeface="BIZ UDPゴシック" panose="020B0400000000000000" pitchFamily="50" charset="-128"/>
                         </a:rPr>
-                        <a:t>〜1週間（MVP 稼働中、既存環境に接続のみ）</a:t>
+                        <a:t>〜1週間（MVP 稼働中、</a:t>
+                      </a:r>
+                      <a:r>
+                        <a:rPr lang="ja-JP" altLang="en-US" sz="1400" b="0">
+                          <a:solidFill>
+                            <a:srgbClr val="111827"/>
+                          </a:solidFill>
+                          <a:latin typeface="BIZ UDPゴシック" panose="020B0400000000000000" pitchFamily="50" charset="-128"/>
+                          <a:ea typeface="BIZ UDPゴシック" panose="020B0400000000000000" pitchFamily="50" charset="-128"/>
+                        </a:rPr>
+                        <a:t>修正要望に応じてプロダクト見直し期間</a:t>
+                      </a:r>
+                      <a:r>
+                        <a:rPr sz="1400" b="0">
+                          <a:solidFill>
+                            <a:srgbClr val="111827"/>
+                          </a:solidFill>
+                          <a:latin typeface="BIZ UDPゴシック" panose="020B0400000000000000" pitchFamily="50" charset="-128"/>
+                          <a:ea typeface="BIZ UDPゴシック" panose="020B0400000000000000" pitchFamily="50" charset="-128"/>
+                        </a:rPr>
+                        <a:t>）</a:t>
                       </a:r>
                     </a:p>
                   </a:txBody>
@@ -15077,7 +15174,7 @@
         </p:nvSpPr>
         <p:spPr>
           <a:xfrm>
-            <a:off x="6217920" y="3017520"/>
+            <a:off x="6217920" y="2969623"/>
             <a:ext cx="5486400" cy="1867988"/>
           </a:xfrm>
           <a:prstGeom prst="rect">
@@ -15141,6 +15238,34 @@
               </a:rPr>
               <a:t>「担当者の勘と経験」に依存（属人化）している。</a:t>
             </a:r>
+            <a:endParaRPr lang="en-US" b="0">
+              <a:solidFill>
+                <a:srgbClr val="111827"/>
+              </a:solidFill>
+              <a:latin typeface="Noto Sans JP"/>
+            </a:endParaRPr>
+          </a:p>
+          <a:p>
+            <a:pPr algn="l">
+              <a:lnSpc>
+                <a:spcPct val="125000"/>
+              </a:lnSpc>
+            </a:pPr>
+            <a:r>
+              <a:rPr lang="ja-JP" altLang="en-US">
+                <a:solidFill>
+                  <a:srgbClr val="111827"/>
+                </a:solidFill>
+                <a:latin typeface="Noto Sans JP"/>
+              </a:rPr>
+              <a:t>また、売れそうな商品と手ごたえはあるが、根拠を示しきれていない</a:t>
+            </a:r>
+            <a:endParaRPr b="0">
+              <a:solidFill>
+                <a:srgbClr val="111827"/>
+              </a:solidFill>
+              <a:latin typeface="Noto Sans JP"/>
+            </a:endParaRPr>
           </a:p>
         </p:txBody>
       </p:sp>
@@ -15152,7 +15277,7 @@
         </p:nvSpPr>
         <p:spPr>
           <a:xfrm>
-            <a:off x="6217920" y="4434840"/>
+            <a:off x="6217920" y="4669972"/>
             <a:ext cx="5486400" cy="1867988"/>
           </a:xfrm>
           <a:prstGeom prst="rect">
@@ -16064,7 +16189,7 @@
 </file>
 
 <file path=ppt/slides/slide21.xml><?xml version="1.0" encoding="utf-8"?>
-<p:sld xmlns:a="http://schemas.openxmlformats.org/drawingml/2006/main" xmlns:p="http://schemas.openxmlformats.org/presentationml/2006/main" xmlns:r="http://schemas.openxmlformats.org/officeDocument/2006/relationships">
+<p:sld xmlns:a="http://schemas.openxmlformats.org/drawingml/2006/main" xmlns:r="http://schemas.openxmlformats.org/officeDocument/2006/relationships" xmlns:p="http://schemas.openxmlformats.org/presentationml/2006/main">
   <p:cSld>
     <p:spTree>
       <p:nvGrpSpPr>
@@ -16072,7 +16197,14 @@
         <p:cNvGrpSpPr/>
         <p:nvPr/>
       </p:nvGrpSpPr>
-      <p:grpSpPr/>
+      <p:grpSpPr>
+        <a:xfrm>
+          <a:off x="0" y="0"/>
+          <a:ext cx="0" cy="0"/>
+          <a:chOff x="0" y="0"/>
+          <a:chExt cx="0" cy="0"/>
+        </a:xfrm>
+      </p:grpSpPr>
       <p:sp>
         <p:nvSpPr>
           <p:cNvPr id="2" name="TextBox 1"/>
@@ -16093,7 +16225,7 @@
           </a:ln>
         </p:spPr>
         <p:txBody>
-          <a:bodyPr wrap="square" anchor="t" lIns="73152" rIns="73152" tIns="36576" bIns="36576">
+          <a:bodyPr wrap="square" lIns="73152" tIns="36576" rIns="73152" bIns="36576" anchor="t">
             <a:spAutoFit/>
           </a:bodyPr>
           <a:lstStyle/>
@@ -16131,7 +16263,7 @@
           </a:ln>
         </p:spPr>
         <p:txBody>
-          <a:bodyPr wrap="square" anchor="t" lIns="73152" rIns="73152" tIns="36576" bIns="36576">
+          <a:bodyPr wrap="square" lIns="73152" tIns="36576" rIns="73152" bIns="36576" anchor="t">
             <a:spAutoFit/>
           </a:bodyPr>
           <a:lstStyle/>
@@ -16169,7 +16301,7 @@
           </a:ln>
         </p:spPr>
         <p:txBody>
-          <a:bodyPr wrap="square" anchor="t" lIns="73152" rIns="73152" tIns="36576" bIns="36576">
+          <a:bodyPr wrap="square" lIns="73152" tIns="36576" rIns="73152" bIns="36576" anchor="t">
             <a:spAutoFit/>
           </a:bodyPr>
           <a:lstStyle/>
@@ -16207,7 +16339,7 @@
           </a:ln>
         </p:spPr>
         <p:txBody>
-          <a:bodyPr wrap="square" anchor="t" lIns="73152" rIns="73152" tIns="36576" bIns="36576">
+          <a:bodyPr wrap="square" lIns="73152" tIns="36576" rIns="73152" bIns="36576" anchor="t">
             <a:spAutoFit/>
           </a:bodyPr>
           <a:lstStyle/>
@@ -16245,7 +16377,7 @@
           </a:ln>
         </p:spPr>
         <p:txBody>
-          <a:bodyPr wrap="square" anchor="t" lIns="73152" rIns="73152" tIns="36576" bIns="36576">
+          <a:bodyPr wrap="square" lIns="73152" tIns="36576" rIns="73152" bIns="36576" anchor="t">
             <a:spAutoFit/>
           </a:bodyPr>
           <a:lstStyle/>
@@ -16325,15 +16457,42 @@
             </a:r>
           </a:p>
           <a:p>
-            <a:r>
-              <a:rPr sz="400" b="0">
+            <a:endParaRPr sz="1100" b="0">
+              <a:solidFill>
+                <a:srgbClr val="111827"/>
+              </a:solidFill>
+              <a:latin typeface="Noto Sans JP"/>
+            </a:endParaRPr>
+          </a:p>
+          <a:p>
+            <a:r>
+              <a:rPr sz="1200" b="1">
+                <a:solidFill>
+                  <a:srgbClr val="1F3A5F"/>
+                </a:solidFill>
+                <a:latin typeface="Noto Sans JP"/>
+              </a:rPr>
+              <a:t>◆ リピート率（PoC 想定例）</a:t>
+            </a:r>
+          </a:p>
+          <a:p>
+            <a:r>
+              <a:rPr sz="1100" b="0">
                 <a:solidFill>
                   <a:srgbClr val="111827"/>
                 </a:solidFill>
                 <a:latin typeface="Noto Sans JP"/>
               </a:rPr>
-              <a:t/>
-            </a:r>
+              <a:t>・大学 30% / 製薬 50%</a:t>
+            </a:r>
+          </a:p>
+          <a:p>
+            <a:endParaRPr sz="1100" b="0">
+              <a:solidFill>
+                <a:srgbClr val="111827"/>
+              </a:solidFill>
+              <a:latin typeface="Noto Sans JP"/>
+            </a:endParaRPr>
           </a:p>
           <a:p>
             <a:r>
@@ -16343,7 +16502,7 @@
                 </a:solidFill>
                 <a:latin typeface="Noto Sans JP"/>
               </a:rPr>
-              <a:t>◆ リピート率（PoC 想定例）</a:t>
+              <a:t>◆ SNS の声（PoC 想定例）</a:t>
             </a:r>
           </a:p>
           <a:p>
@@ -16354,52 +16513,16 @@
                 </a:solidFill>
                 <a:latin typeface="Noto Sans JP"/>
               </a:rPr>
-              <a:t>・大学 30% / 製薬 50%</a:t>
-            </a:r>
-          </a:p>
-          <a:p>
-            <a:r>
-              <a:rPr sz="400" b="0">
-                <a:solidFill>
-                  <a:srgbClr val="111827"/>
-                </a:solidFill>
-                <a:latin typeface="Noto Sans JP"/>
-              </a:rPr>
-              <a:t/>
-            </a:r>
-          </a:p>
-          <a:p>
-            <a:r>
-              <a:rPr sz="1200" b="1">
-                <a:solidFill>
-                  <a:srgbClr val="1F3A5F"/>
-                </a:solidFill>
-                <a:latin typeface="Noto Sans JP"/>
-              </a:rPr>
-              <a:t>◆ SNS の声（PoC 想定例）</a:t>
-            </a:r>
-          </a:p>
-          <a:p>
-            <a:r>
-              <a:rPr sz="1100" b="0">
-                <a:solidFill>
-                  <a:srgbClr val="111827"/>
-                </a:solidFill>
-                <a:latin typeface="Noto Sans JP"/>
-              </a:rPr>
               <a:t>・女性研究者発信 60%（「蓋が重い」 等）</a:t>
             </a:r>
           </a:p>
           <a:p>
-            <a:r>
-              <a:rPr sz="600" b="0">
-                <a:solidFill>
-                  <a:srgbClr val="111827"/>
-                </a:solidFill>
-                <a:latin typeface="Noto Sans JP"/>
-              </a:rPr>
-              <a:t/>
-            </a:r>
+            <a:endParaRPr sz="1100" b="0">
+              <a:solidFill>
+                <a:srgbClr val="111827"/>
+              </a:solidFill>
+              <a:latin typeface="Noto Sans JP"/>
+            </a:endParaRPr>
           </a:p>
           <a:p>
             <a:r>
@@ -16445,7 +16568,7 @@
           </a:ln>
         </p:spPr>
         <p:txBody>
-          <a:bodyPr wrap="square" anchor="t" lIns="73152" rIns="73152" tIns="36576" bIns="36576">
+          <a:bodyPr wrap="square" lIns="73152" tIns="36576" rIns="73152" bIns="36576" anchor="t">
             <a:spAutoFit/>
           </a:bodyPr>
           <a:lstStyle/>
@@ -16514,15 +16637,42 @@
             </a:r>
           </a:p>
           <a:p>
-            <a:r>
-              <a:rPr sz="400" b="0">
+            <a:endParaRPr sz="1100" b="0">
+              <a:solidFill>
+                <a:srgbClr val="111827"/>
+              </a:solidFill>
+              <a:latin typeface="Noto Sans JP"/>
+            </a:endParaRPr>
+          </a:p>
+          <a:p>
+            <a:r>
+              <a:rPr sz="1200" b="1">
+                <a:solidFill>
+                  <a:srgbClr val="1F3A5F"/>
+                </a:solidFill>
+                <a:latin typeface="Noto Sans JP"/>
+              </a:rPr>
+              <a:t>◆ 既存 PB ラインアップ</a:t>
+            </a:r>
+          </a:p>
+          <a:p>
+            <a:r>
+              <a:rPr sz="1100" b="0">
                 <a:solidFill>
                   <a:srgbClr val="111827"/>
                 </a:solidFill>
                 <a:latin typeface="Noto Sans JP"/>
               </a:rPr>
-              <a:t/>
-            </a:r>
+              <a:t>・実カタログ・商品マスタ</a:t>
+            </a:r>
+          </a:p>
+          <a:p>
+            <a:endParaRPr sz="1100" b="0">
+              <a:solidFill>
+                <a:srgbClr val="111827"/>
+              </a:solidFill>
+              <a:latin typeface="Noto Sans JP"/>
+            </a:endParaRPr>
           </a:p>
           <a:p>
             <a:r>
@@ -16532,7 +16682,7 @@
                 </a:solidFill>
                 <a:latin typeface="Noto Sans JP"/>
               </a:rPr>
-              <a:t>◆ 既存 PB ラインアップ</a:t>
+              <a:t>◆ SNS 観測</a:t>
             </a:r>
           </a:p>
           <a:p>
@@ -16543,85 +16693,46 @@
                 </a:solidFill>
                 <a:latin typeface="Noto Sans JP"/>
               </a:rPr>
-              <a:t>・実カタログ・商品マスタ</a:t>
-            </a:r>
-          </a:p>
-          <a:p>
-            <a:r>
-              <a:rPr sz="400" b="0">
+              <a:t>・実クエリ × 実発信内容</a:t>
+            </a:r>
+          </a:p>
+          <a:p>
+            <a:endParaRPr sz="1100" b="0">
+              <a:solidFill>
+                <a:srgbClr val="111827"/>
+              </a:solidFill>
+              <a:latin typeface="Noto Sans JP"/>
+            </a:endParaRPr>
+          </a:p>
+          <a:p>
+            <a:r>
+              <a:rPr sz="1200" b="1">
+                <a:solidFill>
+                  <a:srgbClr val="1F3A5F"/>
+                </a:solidFill>
+                <a:latin typeface="Noto Sans JP"/>
+              </a:rPr>
+              <a:t>◆ 業界レポート</a:t>
+            </a:r>
+          </a:p>
+          <a:p>
+            <a:r>
+              <a:rPr sz="1100" b="0">
                 <a:solidFill>
                   <a:srgbClr val="111827"/>
                 </a:solidFill>
                 <a:latin typeface="Noto Sans JP"/>
               </a:rPr>
-              <a:t/>
-            </a:r>
-          </a:p>
-          <a:p>
-            <a:r>
-              <a:rPr sz="1200" b="1">
-                <a:solidFill>
-                  <a:srgbClr val="1F3A5F"/>
-                </a:solidFill>
-                <a:latin typeface="Noto Sans JP"/>
-              </a:rPr>
-              <a:t>◆ SNS 観測</a:t>
-            </a:r>
-          </a:p>
-          <a:p>
-            <a:r>
-              <a:rPr sz="1100" b="0">
-                <a:solidFill>
-                  <a:srgbClr val="111827"/>
-                </a:solidFill>
-                <a:latin typeface="Noto Sans JP"/>
-              </a:rPr>
-              <a:t>・実クエリ × 実発信内容</a:t>
-            </a:r>
-          </a:p>
-          <a:p>
-            <a:r>
-              <a:rPr sz="400" b="0">
-                <a:solidFill>
-                  <a:srgbClr val="111827"/>
-                </a:solidFill>
-                <a:latin typeface="Noto Sans JP"/>
-              </a:rPr>
-              <a:t/>
-            </a:r>
-          </a:p>
-          <a:p>
-            <a:r>
-              <a:rPr sz="1200" b="1">
-                <a:solidFill>
-                  <a:srgbClr val="1F3A5F"/>
-                </a:solidFill>
-                <a:latin typeface="Noto Sans JP"/>
-              </a:rPr>
-              <a:t>◆ 業界レポート</a:t>
-            </a:r>
-          </a:p>
-          <a:p>
-            <a:r>
-              <a:rPr sz="1100" b="0">
-                <a:solidFill>
-                  <a:srgbClr val="111827"/>
-                </a:solidFill>
-                <a:latin typeface="Noto Sans JP"/>
-              </a:rPr>
               <a:t>・矢野経済研・富士経済など（有償）</a:t>
             </a:r>
           </a:p>
           <a:p>
-            <a:r>
-              <a:rPr sz="600" b="0">
-                <a:solidFill>
-                  <a:srgbClr val="111827"/>
-                </a:solidFill>
-                <a:latin typeface="Noto Sans JP"/>
-              </a:rPr>
-              <a:t/>
-            </a:r>
+            <a:endParaRPr sz="1100" b="0">
+              <a:solidFill>
+                <a:srgbClr val="111827"/>
+              </a:solidFill>
+              <a:latin typeface="Noto Sans JP"/>
+            </a:endParaRPr>
           </a:p>
           <a:p>
             <a:r>
@@ -23832,7 +23943,7 @@
 </file>
 
 <file path=ppt/theme/theme2.xml><?xml version="1.0" encoding="utf-8"?>
-<a:theme xmlns:a="http://schemas.openxmlformats.org/drawingml/2006/main" name="Office Theme">
+<a:theme xmlns:a="http://schemas.openxmlformats.org/drawingml/2006/main" name="Office テーマ">
   <a:themeElements>
     <a:clrScheme name="Office">
       <a:dk1>
@@ -23842,44 +23953,44 @@
         <a:sysClr val="window" lastClr="FFFFFF"/>
       </a:lt1>
       <a:dk2>
-        <a:srgbClr val="1F497D"/>
+        <a:srgbClr val="0E2841"/>
       </a:dk2>
       <a:lt2>
-        <a:srgbClr val="EEECE1"/>
+        <a:srgbClr val="E8E8E8"/>
       </a:lt2>
       <a:accent1>
-        <a:srgbClr val="4F81BD"/>
+        <a:srgbClr val="156082"/>
       </a:accent1>
       <a:accent2>
-        <a:srgbClr val="C0504D"/>
+        <a:srgbClr val="E97132"/>
       </a:accent2>
       <a:accent3>
-        <a:srgbClr val="9BBB59"/>
+        <a:srgbClr val="196B24"/>
       </a:accent3>
       <a:accent4>
-        <a:srgbClr val="8064A2"/>
+        <a:srgbClr val="0F9ED5"/>
       </a:accent4>
       <a:accent5>
-        <a:srgbClr val="4BACC6"/>
+        <a:srgbClr val="A02B93"/>
       </a:accent5>
       <a:accent6>
-        <a:srgbClr val="F79646"/>
+        <a:srgbClr val="4EA72E"/>
       </a:accent6>
       <a:hlink>
-        <a:srgbClr val="0000FF"/>
+        <a:srgbClr val="467886"/>
       </a:hlink>
       <a:folHlink>
-        <a:srgbClr val="800080"/>
+        <a:srgbClr val="96607D"/>
       </a:folHlink>
     </a:clrScheme>
     <a:fontScheme name="Office">
       <a:majorFont>
-        <a:latin typeface="Calibri"/>
+        <a:latin typeface="游ゴシック Light" panose="02110004020202020204"/>
         <a:ea typeface=""/>
         <a:cs typeface=""/>
-        <a:font script="Jpan" typeface="ＭＳ Ｐゴシック"/>
+        <a:font script="Jpan" typeface="游ゴシック Light"/>
         <a:font script="Hang" typeface="맑은 고딕"/>
-        <a:font script="Hans" typeface="宋体"/>
+        <a:font script="Hans" typeface="等线 Light"/>
         <a:font script="Hant" typeface="新細明體"/>
         <a:font script="Arab" typeface="Times New Roman"/>
         <a:font script="Hebr" typeface="Times New Roman"/>
@@ -23907,14 +24018,31 @@
         <a:font script="Viet" typeface="Times New Roman"/>
         <a:font script="Uigh" typeface="Microsoft Uighur"/>
         <a:font script="Geor" typeface="Sylfaen"/>
+        <a:font script="Armn" typeface="Arial"/>
+        <a:font script="Bugi" typeface="Leelawadee UI"/>
+        <a:font script="Bopo" typeface="Microsoft JhengHei"/>
+        <a:font script="Java" typeface="Javanese Text"/>
+        <a:font script="Lisu" typeface="Segoe UI"/>
+        <a:font script="Mymr" typeface="Myanmar Text"/>
+        <a:font script="Nkoo" typeface="Ebrima"/>
+        <a:font script="Olck" typeface="Nirmala UI"/>
+        <a:font script="Osma" typeface="Ebrima"/>
+        <a:font script="Phag" typeface="Phagspa"/>
+        <a:font script="Syrn" typeface="Estrangelo Edessa"/>
+        <a:font script="Syrj" typeface="Estrangelo Edessa"/>
+        <a:font script="Syre" typeface="Estrangelo Edessa"/>
+        <a:font script="Sora" typeface="Nirmala UI"/>
+        <a:font script="Tale" typeface="Microsoft Tai Le"/>
+        <a:font script="Talu" typeface="Microsoft New Tai Lue"/>
+        <a:font script="Tfng" typeface="Ebrima"/>
       </a:majorFont>
       <a:minorFont>
-        <a:latin typeface="Calibri"/>
+        <a:latin typeface="游ゴシック" panose="02110004020202020204"/>
         <a:ea typeface=""/>
         <a:cs typeface=""/>
-        <a:font script="Jpan" typeface="ＭＳ Ｐゴシック"/>
+        <a:font script="Jpan" typeface="游ゴシック"/>
         <a:font script="Hang" typeface="맑은 고딕"/>
-        <a:font script="Hans" typeface="宋体"/>
+        <a:font script="Hans" typeface="等线"/>
         <a:font script="Hant" typeface="新細明體"/>
         <a:font script="Arab" typeface="Arial"/>
         <a:font script="Hebr" typeface="Arial"/>
@@ -23942,6 +24070,23 @@
         <a:font script="Viet" typeface="Arial"/>
         <a:font script="Uigh" typeface="Microsoft Uighur"/>
         <a:font script="Geor" typeface="Sylfaen"/>
+        <a:font script="Armn" typeface="Arial"/>
+        <a:font script="Bugi" typeface="Leelawadee UI"/>
+        <a:font script="Bopo" typeface="Microsoft JhengHei"/>
+        <a:font script="Java" typeface="Javanese Text"/>
+        <a:font script="Lisu" typeface="Segoe UI"/>
+        <a:font script="Mymr" typeface="Myanmar Text"/>
+        <a:font script="Nkoo" typeface="Ebrima"/>
+        <a:font script="Olck" typeface="Nirmala UI"/>
+        <a:font script="Osma" typeface="Ebrima"/>
+        <a:font script="Phag" typeface="Phagspa"/>
+        <a:font script="Syrn" typeface="Estrangelo Edessa"/>
+        <a:font script="Syrj" typeface="Estrangelo Edessa"/>
+        <a:font script="Syre" typeface="Estrangelo Edessa"/>
+        <a:font script="Sora" typeface="Nirmala UI"/>
+        <a:font script="Tale" typeface="Microsoft Tai Le"/>
+        <a:font script="Talu" typeface="Microsoft New Tai Lue"/>
+        <a:font script="Tfng" typeface="Ebrima"/>
       </a:minorFont>
     </a:fontScheme>
     <a:fmtScheme name="Office">
@@ -23953,180 +24098,136 @@
           <a:gsLst>
             <a:gs pos="0">
               <a:schemeClr val="phClr">
-                <a:tint val="50000"/>
-                <a:satMod val="300000"/>
+                <a:lumMod val="110000"/>
+                <a:satMod val="105000"/>
+                <a:tint val="67000"/>
               </a:schemeClr>
             </a:gs>
-            <a:gs pos="35000">
+            <a:gs pos="50000">
               <a:schemeClr val="phClr">
-                <a:tint val="37000"/>
-                <a:satMod val="300000"/>
+                <a:lumMod val="105000"/>
+                <a:satMod val="103000"/>
+                <a:tint val="73000"/>
               </a:schemeClr>
             </a:gs>
             <a:gs pos="100000">
               <a:schemeClr val="phClr">
-                <a:tint val="15000"/>
-                <a:satMod val="350000"/>
+                <a:lumMod val="105000"/>
+                <a:satMod val="109000"/>
+                <a:tint val="81000"/>
               </a:schemeClr>
             </a:gs>
           </a:gsLst>
-          <a:lin ang="16200000" scaled="1"/>
+          <a:lin ang="5400000" scaled="0"/>
         </a:gradFill>
         <a:gradFill rotWithShape="1">
           <a:gsLst>
             <a:gs pos="0">
               <a:schemeClr val="phClr">
-                <a:tint val="100000"/>
+                <a:satMod val="103000"/>
+                <a:lumMod val="102000"/>
+                <a:tint val="94000"/>
+              </a:schemeClr>
+            </a:gs>
+            <a:gs pos="50000">
+              <a:schemeClr val="phClr">
+                <a:satMod val="110000"/>
+                <a:lumMod val="100000"/>
                 <a:shade val="100000"/>
-                <a:satMod val="130000"/>
               </a:schemeClr>
             </a:gs>
             <a:gs pos="100000">
               <a:schemeClr val="phClr">
-                <a:tint val="50000"/>
-                <a:shade val="100000"/>
-                <a:satMod val="350000"/>
+                <a:lumMod val="99000"/>
+                <a:satMod val="120000"/>
+                <a:shade val="78000"/>
               </a:schemeClr>
             </a:gs>
           </a:gsLst>
-          <a:lin ang="16200000" scaled="0"/>
+          <a:lin ang="5400000" scaled="0"/>
         </a:gradFill>
       </a:fillStyleLst>
       <a:lnStyleLst>
-        <a:ln w="9525" cap="flat" cmpd="sng" algn="ctr">
+        <a:ln w="12700" cap="flat" cmpd="sng" algn="ctr">
           <a:solidFill>
-            <a:schemeClr val="phClr">
-              <a:shade val="95000"/>
-              <a:satMod val="105000"/>
-            </a:schemeClr>
+            <a:schemeClr val="phClr"/>
           </a:solidFill>
           <a:prstDash val="solid"/>
+          <a:miter lim="800000"/>
+        </a:ln>
+        <a:ln w="19050" cap="flat" cmpd="sng" algn="ctr">
+          <a:solidFill>
+            <a:schemeClr val="phClr"/>
+          </a:solidFill>
+          <a:prstDash val="solid"/>
+          <a:miter lim="800000"/>
         </a:ln>
         <a:ln w="25400" cap="flat" cmpd="sng" algn="ctr">
           <a:solidFill>
             <a:schemeClr val="phClr"/>
           </a:solidFill>
           <a:prstDash val="solid"/>
-        </a:ln>
-        <a:ln w="38100" cap="flat" cmpd="sng" algn="ctr">
-          <a:solidFill>
-            <a:schemeClr val="phClr"/>
-          </a:solidFill>
-          <a:prstDash val="solid"/>
+          <a:miter lim="800000"/>
         </a:ln>
       </a:lnStyleLst>
       <a:effectStyleLst>
         <a:effectStyle>
+          <a:effectLst/>
+        </a:effectStyle>
+        <a:effectStyle>
+          <a:effectLst/>
+        </a:effectStyle>
+        <a:effectStyle>
           <a:effectLst>
-            <a:outerShdw blurRad="40000" dist="20000" dir="5400000" rotWithShape="0">
+            <a:outerShdw blurRad="57150" dist="19050" dir="5400000" algn="ctr" rotWithShape="0">
               <a:srgbClr val="000000">
-                <a:alpha val="38000"/>
+                <a:alpha val="63000"/>
               </a:srgbClr>
             </a:outerShdw>
           </a:effectLst>
-        </a:effectStyle>
-        <a:effectStyle>
-          <a:effectLst>
-            <a:outerShdw blurRad="40000" dist="23000" dir="5400000" rotWithShape="0">
-              <a:srgbClr val="000000">
-                <a:alpha val="35000"/>
-              </a:srgbClr>
-            </a:outerShdw>
-          </a:effectLst>
-        </a:effectStyle>
-        <a:effectStyle>
-          <a:effectLst>
-            <a:outerShdw blurRad="40000" dist="23000" dir="5400000" rotWithShape="0">
-              <a:srgbClr val="000000">
-                <a:alpha val="35000"/>
-              </a:srgbClr>
-            </a:outerShdw>
-          </a:effectLst>
-          <a:scene3d>
-            <a:camera prst="orthographicFront">
-              <a:rot lat="0" lon="0" rev="0"/>
-            </a:camera>
-            <a:lightRig rig="threePt" dir="t">
-              <a:rot lat="0" lon="0" rev="1200000"/>
-            </a:lightRig>
-          </a:scene3d>
-          <a:sp3d>
-            <a:bevelT w="63500" h="25400"/>
-          </a:sp3d>
         </a:effectStyle>
       </a:effectStyleLst>
       <a:bgFillStyleLst>
         <a:solidFill>
           <a:schemeClr val="phClr"/>
         </a:solidFill>
+        <a:solidFill>
+          <a:schemeClr val="phClr">
+            <a:tint val="95000"/>
+            <a:satMod val="170000"/>
+          </a:schemeClr>
+        </a:solidFill>
         <a:gradFill rotWithShape="1">
           <a:gsLst>
             <a:gs pos="0">
               <a:schemeClr val="phClr">
-                <a:tint val="40000"/>
-                <a:satMod val="350000"/>
+                <a:tint val="93000"/>
+                <a:satMod val="150000"/>
+                <a:shade val="98000"/>
+                <a:lumMod val="102000"/>
               </a:schemeClr>
             </a:gs>
-            <a:gs pos="40000">
+            <a:gs pos="50000">
               <a:schemeClr val="phClr">
-                <a:tint val="45000"/>
-                <a:shade val="99000"/>
-                <a:satMod val="350000"/>
+                <a:tint val="98000"/>
+                <a:satMod val="130000"/>
+                <a:shade val="90000"/>
+                <a:lumMod val="103000"/>
               </a:schemeClr>
             </a:gs>
             <a:gs pos="100000">
               <a:schemeClr val="phClr">
-                <a:shade val="20000"/>
-                <a:satMod val="255000"/>
+                <a:shade val="63000"/>
+                <a:satMod val="120000"/>
               </a:schemeClr>
             </a:gs>
           </a:gsLst>
-          <a:path path="circle">
-            <a:fillToRect l="50000" t="-80000" r="50000" b="180000"/>
-          </a:path>
-        </a:gradFill>
-        <a:gradFill rotWithShape="1">
-          <a:gsLst>
-            <a:gs pos="0">
-              <a:schemeClr val="phClr">
-                <a:tint val="80000"/>
-                <a:satMod val="300000"/>
-              </a:schemeClr>
-            </a:gs>
-            <a:gs pos="100000">
-              <a:schemeClr val="phClr">
-                <a:shade val="30000"/>
-                <a:satMod val="200000"/>
-              </a:schemeClr>
-            </a:gs>
-          </a:gsLst>
-          <a:path path="circle">
-            <a:fillToRect l="50000" t="50000" r="50000" b="50000"/>
-          </a:path>
+          <a:lin ang="5400000" scaled="0"/>
         </a:gradFill>
       </a:bgFillStyleLst>
     </a:fmtScheme>
   </a:themeElements>
   <a:objectDefaults>
-    <a:spDef>
-      <a:spPr/>
-      <a:bodyPr/>
-      <a:lstStyle/>
-      <a:style>
-        <a:lnRef idx="1">
-          <a:schemeClr val="accent1"/>
-        </a:lnRef>
-        <a:fillRef idx="3">
-          <a:schemeClr val="accent1"/>
-        </a:fillRef>
-        <a:effectRef idx="2">
-          <a:schemeClr val="accent1"/>
-        </a:effectRef>
-        <a:fontRef idx="minor">
-          <a:schemeClr val="lt1"/>
-        </a:fontRef>
-      </a:style>
-    </a:spDef>
     <a:lnDef>
       <a:spPr/>
       <a:bodyPr/>
@@ -24148,5 +24249,10 @@
     </a:lnDef>
   </a:objectDefaults>
   <a:extraClrSchemeLst/>
+  <a:extLst>
+    <a:ext uri="{05A4C25C-085E-4340-85A3-A5531E510DB2}">
+      <thm15:themeFamily xmlns:thm15="http://schemas.microsoft.com/office/thememl/2012/main" name="Office Theme" id="{2E142A2C-CD16-42D6-873A-C26D2A0506FA}" vid="{1BDDFF52-6CD6-40A5-AB3C-68EB2F1E4D0A}"/>
+    </a:ext>
+  </a:extLst>
 </a:theme>
 </file>
</xml_diff>